<commit_message>
Add correction By EL Hadiq Lab 1.1
</commit_message>
<xml_diff>
--- a/Presentation/Discrete_Math_ACSP_FirstMeeting.pptx
+++ b/Presentation/Discrete_Math_ACSP_FirstMeeting.pptx
@@ -116,6 +116,41 @@
     </p:ext>
   </p:extLst>
 </p:presentation>
+</file>
+
+<file path=ppt/commentAuthors.xml><?xml version="1.0" encoding="utf-8"?>
+<p:cmAuthorLst xmlns:a="http://schemas.openxmlformats.org/drawingml/2006/main" xmlns:r="http://schemas.openxmlformats.org/officeDocument/2006/relationships" xmlns:p="http://schemas.openxmlformats.org/presentationml/2006/main">
+  <p:cmAuthor id="1" name="El Hadiq Zouhair" initials="EZ" lastIdx="1" clrIdx="0">
+    <p:extLst>
+      <p:ext uri="{19B8F6BF-5375-455C-9EA6-DF929625EA0E}">
+        <p15:presenceInfo xmlns:p15="http://schemas.microsoft.com/office/powerpoint/2012/main" userId="eeabc8a731369975" providerId="Windows Live"/>
+      </p:ext>
+    </p:extLst>
+  </p:cmAuthor>
+</p:cmAuthorLst>
+</file>
+
+<file path=ppt/revisionInfo.xml><?xml version="1.0" encoding="utf-8"?>
+<p1510:revInfo xmlns:a="http://schemas.openxmlformats.org/drawingml/2006/main" xmlns:r="http://schemas.openxmlformats.org/officeDocument/2006/relationships" xmlns:p1510="http://schemas.microsoft.com/office/powerpoint/2015/10/main">
+  <p1510:revLst>
+    <p1510:client id="{09AF0D45-A366-8701-C0FC-4E7934F45662}" v="1" dt="2026-05-08T16:46:22.165"/>
+    <p1510:client id="{EFD29175-0FAD-78EA-358B-898EEFC90C09}" v="44" dt="2026-05-08T13:19:03.786"/>
+  </p1510:revLst>
+</p1510:revInfo>
+</file>
+
+<file path=ppt/comments/comment1.xml><?xml version="1.0" encoding="utf-8"?>
+<p:cmLst xmlns:a="http://schemas.openxmlformats.org/drawingml/2006/main" xmlns:r="http://schemas.openxmlformats.org/officeDocument/2006/relationships" xmlns:p="http://schemas.openxmlformats.org/presentationml/2006/main">
+  <p:cm authorId="1" dt="2026-05-07T22:54:37.484" idx="1">
+    <p:pos x="10" y="10"/>
+    <p:text/>
+    <p:extLst>
+      <p:ext uri="{C676402C-5697-4E1C-873F-D02D1690AC5C}">
+        <p15:threadingInfo xmlns:p15="http://schemas.microsoft.com/office/powerpoint/2012/main" timeZoneBias="-60"/>
+      </p:ext>
+    </p:extLst>
+  </p:cm>
+</p:cmLst>
 </file>
 
 <file path=ppt/notesMasters/notesMaster1.xml><?xml version="1.0" encoding="utf-8"?>
@@ -271,6 +306,13 @@
           </p:nvPr>
         </p:nvSpPr>
         <p:spPr/>
+        <p:txBody>
+          <a:bodyPr/>
+          <a:lstStyle/>
+          <a:p>
+            <a:endParaRPr lang="fr-MA"/>
+          </a:p>
+        </p:txBody>
       </p:sp>
       <p:sp>
         <p:nvSpPr>
@@ -355,6 +397,13 @@
           </p:nvPr>
         </p:nvSpPr>
         <p:spPr/>
+        <p:txBody>
+          <a:bodyPr/>
+          <a:lstStyle/>
+          <a:p>
+            <a:endParaRPr lang="fr-MA"/>
+          </a:p>
+        </p:txBody>
       </p:sp>
       <p:sp>
         <p:nvSpPr>
@@ -439,6 +488,13 @@
           </p:nvPr>
         </p:nvSpPr>
         <p:spPr/>
+        <p:txBody>
+          <a:bodyPr/>
+          <a:lstStyle/>
+          <a:p>
+            <a:endParaRPr lang="fr-MA"/>
+          </a:p>
+        </p:txBody>
       </p:sp>
       <p:sp>
         <p:nvSpPr>
@@ -523,6 +579,13 @@
           </p:nvPr>
         </p:nvSpPr>
         <p:spPr/>
+        <p:txBody>
+          <a:bodyPr/>
+          <a:lstStyle/>
+          <a:p>
+            <a:endParaRPr lang="fr-MA"/>
+          </a:p>
+        </p:txBody>
       </p:sp>
       <p:sp>
         <p:nvSpPr>
@@ -607,6 +670,13 @@
           </p:nvPr>
         </p:nvSpPr>
         <p:spPr/>
+        <p:txBody>
+          <a:bodyPr/>
+          <a:lstStyle/>
+          <a:p>
+            <a:endParaRPr lang="fr-MA"/>
+          </a:p>
+        </p:txBody>
       </p:sp>
       <p:sp>
         <p:nvSpPr>
@@ -691,6 +761,13 @@
           </p:nvPr>
         </p:nvSpPr>
         <p:spPr/>
+        <p:txBody>
+          <a:bodyPr/>
+          <a:lstStyle/>
+          <a:p>
+            <a:endParaRPr lang="fr-MA"/>
+          </a:p>
+        </p:txBody>
       </p:sp>
       <p:sp>
         <p:nvSpPr>
@@ -775,6 +852,13 @@
           </p:nvPr>
         </p:nvSpPr>
         <p:spPr/>
+        <p:txBody>
+          <a:bodyPr/>
+          <a:lstStyle/>
+          <a:p>
+            <a:endParaRPr lang="fr-MA"/>
+          </a:p>
+        </p:txBody>
       </p:sp>
       <p:sp>
         <p:nvSpPr>
@@ -1170,54 +1254,131 @@
       </p:grpSpPr>
       <p:sp>
         <p:nvSpPr>
-          <p:cNvPr id="2" name="Shape 0"/>
-          <p:cNvSpPr/>
-          <p:nvPr/>
-        </p:nvSpPr>
-        <p:spPr>
-          <a:xfrm>
-            <a:off x="8778240" y="5029200"/>
-            <a:ext cx="2926080" cy="164592"/>
-          </a:xfrm>
-          <a:prstGeom prst="rect">
-            <a:avLst/>
-          </a:prstGeom>
-          <a:solidFill>
-            <a:srgbClr val="22D3EE"/>
-          </a:solidFill>
-          <a:ln/>
-        </p:spPr>
-      </p:sp>
-      <p:sp>
-        <p:nvSpPr>
-          <p:cNvPr id="3" name="Shape 1"/>
-          <p:cNvSpPr/>
-          <p:nvPr/>
-        </p:nvSpPr>
-        <p:spPr>
-          <a:xfrm>
-            <a:off x="9326880" y="5349240"/>
-            <a:ext cx="2377440" cy="164592"/>
-          </a:xfrm>
-          <a:prstGeom prst="rect">
-            <a:avLst/>
-          </a:prstGeom>
-          <a:solidFill>
-            <a:srgbClr val="0891B2"/>
-          </a:solidFill>
-          <a:ln/>
-        </p:spPr>
-      </p:sp>
-      <p:sp>
-        <p:nvSpPr>
-          <p:cNvPr id="4" name="Shape 2"/>
-          <p:cNvSpPr/>
-          <p:nvPr/>
-        </p:nvSpPr>
-        <p:spPr>
-          <a:xfrm>
-            <a:off x="9875520" y="5669280"/>
-            <a:ext cx="1828800" cy="164592"/>
+          <p:cNvPr id="7" name="Text 5"/>
+          <p:cNvSpPr/>
+          <p:nvPr/>
+        </p:nvSpPr>
+        <p:spPr>
+          <a:xfrm>
+            <a:off x="548640" y="1645920"/>
+            <a:ext cx="9144000" cy="320040"/>
+          </a:xfrm>
+          <a:prstGeom prst="rect">
+            <a:avLst/>
+          </a:prstGeom>
+          <a:noFill/>
+          <a:ln/>
+        </p:spPr>
+        <p:txBody>
+          <a:bodyPr wrap="square" lIns="0" tIns="0" rIns="0" bIns="0" rtlCol="0" anchor="ctr"/>
+          <a:lstStyle/>
+          <a:p>
+            <a:pPr marL="0" indent="0">
+              <a:buNone/>
+            </a:pPr>
+            <a:r>
+              <a:rPr lang="en-US" sz="1200" b="1" kern="0" spc="600" dirty="0">
+                <a:solidFill>
+                  <a:srgbClr val="22D3EE"/>
+                </a:solidFill>
+                <a:latin typeface="Calibri" pitchFamily="34" charset="0"/>
+                <a:ea typeface="Calibri" pitchFamily="34" charset="-122"/>
+                <a:cs typeface="Calibri" pitchFamily="34" charset="-120"/>
+              </a:rPr>
+              <a:t>FIRST-MEETING ORIENTATION</a:t>
+            </a:r>
+            <a:endParaRPr lang="en-US" sz="1200" dirty="0"/>
+          </a:p>
+        </p:txBody>
+      </p:sp>
+      <p:sp>
+        <p:nvSpPr>
+          <p:cNvPr id="8" name="Text 6"/>
+          <p:cNvSpPr/>
+          <p:nvPr/>
+        </p:nvSpPr>
+        <p:spPr>
+          <a:xfrm>
+            <a:off x="548640" y="2011680"/>
+            <a:ext cx="10972800" cy="1188720"/>
+          </a:xfrm>
+          <a:prstGeom prst="rect">
+            <a:avLst/>
+          </a:prstGeom>
+          <a:noFill/>
+          <a:ln/>
+        </p:spPr>
+        <p:txBody>
+          <a:bodyPr wrap="square" lIns="0" tIns="0" rIns="0" bIns="0" rtlCol="0" anchor="ctr"/>
+          <a:lstStyle/>
+          <a:p>
+            <a:pPr marL="0" indent="0">
+              <a:buNone/>
+            </a:pPr>
+            <a:r>
+              <a:rPr lang="en-US" sz="6400" b="1" dirty="0">
+                <a:solidFill>
+                  <a:srgbClr val="FFFFFF"/>
+                </a:solidFill>
+                <a:latin typeface="Georgia" pitchFamily="34" charset="0"/>
+                <a:ea typeface="Georgia" pitchFamily="34" charset="-122"/>
+                <a:cs typeface="Georgia" pitchFamily="34" charset="-120"/>
+              </a:rPr>
+              <a:t>Discrete Mathematics</a:t>
+            </a:r>
+            <a:endParaRPr lang="en-US" sz="6400" dirty="0"/>
+          </a:p>
+        </p:txBody>
+      </p:sp>
+      <p:sp>
+        <p:nvSpPr>
+          <p:cNvPr id="9" name="Text 7"/>
+          <p:cNvSpPr/>
+          <p:nvPr/>
+        </p:nvSpPr>
+        <p:spPr>
+          <a:xfrm>
+            <a:off x="548640" y="3154680"/>
+            <a:ext cx="10972800" cy="548640"/>
+          </a:xfrm>
+          <a:prstGeom prst="rect">
+            <a:avLst/>
+          </a:prstGeom>
+          <a:noFill/>
+          <a:ln/>
+        </p:spPr>
+        <p:txBody>
+          <a:bodyPr wrap="square" lIns="0" tIns="0" rIns="0" bIns="0" rtlCol="0" anchor="ctr"/>
+          <a:lstStyle/>
+          <a:p>
+            <a:pPr marL="0" indent="0">
+              <a:buNone/>
+            </a:pPr>
+            <a:r>
+              <a:rPr lang="en-US" sz="2600" i="1" dirty="0">
+                <a:solidFill>
+                  <a:srgbClr val="22D3EE"/>
+                </a:solidFill>
+                <a:latin typeface="Georgia" pitchFamily="34" charset="0"/>
+                <a:ea typeface="Georgia" pitchFamily="34" charset="-122"/>
+                <a:cs typeface="Georgia" pitchFamily="34" charset="-120"/>
+              </a:rPr>
+              <a:t>Foundations for Computer Science</a:t>
+            </a:r>
+            <a:endParaRPr lang="en-US" sz="2600" dirty="0"/>
+          </a:p>
+        </p:txBody>
+      </p:sp>
+      <p:sp>
+        <p:nvSpPr>
+          <p:cNvPr id="10" name="Shape 8"/>
+          <p:cNvSpPr/>
+          <p:nvPr/>
+        </p:nvSpPr>
+        <p:spPr>
+          <a:xfrm>
+            <a:off x="548640" y="4023360"/>
+            <a:ext cx="731520" cy="45720"/>
           </a:xfrm>
           <a:prstGeom prst="rect">
             <a:avLst/>
@@ -1227,44 +1388,24 @@
           </a:solidFill>
           <a:ln/>
         </p:spPr>
-      </p:sp>
-      <p:sp>
-        <p:nvSpPr>
-          <p:cNvPr id="5" name="Shape 3"/>
-          <p:cNvSpPr/>
-          <p:nvPr/>
-        </p:nvSpPr>
-        <p:spPr>
-          <a:xfrm>
-            <a:off x="548640" y="502920"/>
-            <a:ext cx="2103120" cy="365760"/>
-          </a:xfrm>
-          <a:prstGeom prst="roundRect">
-            <a:avLst>
-              <a:gd name="adj" fmla="val 12500"/>
-            </a:avLst>
-          </a:prstGeom>
-          <a:solidFill>
-            <a:srgbClr val="0F172A"/>
-          </a:solidFill>
-          <a:ln w="9525">
-            <a:solidFill>
-              <a:srgbClr val="22D3EE"/>
-            </a:solidFill>
-            <a:prstDash val="solid"/>
-          </a:ln>
-        </p:spPr>
-      </p:sp>
-      <p:sp>
-        <p:nvSpPr>
-          <p:cNvPr id="6" name="Text 4"/>
-          <p:cNvSpPr/>
-          <p:nvPr/>
-        </p:nvSpPr>
-        <p:spPr>
-          <a:xfrm>
-            <a:off x="548640" y="502920"/>
-            <a:ext cx="2103120" cy="365760"/>
+        <p:txBody>
+          <a:bodyPr/>
+          <a:lstStyle/>
+          <a:p>
+            <a:endParaRPr lang="fr-MA"/>
+          </a:p>
+        </p:txBody>
+      </p:sp>
+      <p:sp>
+        <p:nvSpPr>
+          <p:cNvPr id="11" name="Text 9"/>
+          <p:cNvSpPr/>
+          <p:nvPr/>
+        </p:nvSpPr>
+        <p:spPr>
+          <a:xfrm>
+            <a:off x="548640" y="4160520"/>
+            <a:ext cx="3657600" cy="274320"/>
           </a:xfrm>
           <a:prstGeom prst="rect">
             <a:avLst/>
@@ -1276,34 +1417,34 @@
           <a:bodyPr wrap="square" lIns="0" tIns="0" rIns="0" bIns="0" rtlCol="0" anchor="ctr"/>
           <a:lstStyle/>
           <a:p>
-            <a:pPr marL="0" indent="0" algn="ctr">
-              <a:buNone/>
-            </a:pPr>
-            <a:r>
-              <a:rPr lang="en-US" sz="1000" b="1" kern="0" spc="300" dirty="0">
-                <a:solidFill>
-                  <a:srgbClr val="22D3EE"/>
+            <a:pPr marL="0" indent="0">
+              <a:buNone/>
+            </a:pPr>
+            <a:r>
+              <a:rPr lang="en-US" sz="1100" b="1" kern="0" spc="400" dirty="0">
+                <a:solidFill>
+                  <a:srgbClr val="64748B"/>
                 </a:solidFill>
                 <a:latin typeface="Calibri" pitchFamily="34" charset="0"/>
                 <a:ea typeface="Calibri" pitchFamily="34" charset="-122"/>
                 <a:cs typeface="Calibri" pitchFamily="34" charset="-120"/>
               </a:rPr>
-              <a:t>DMath_CC_25 · ACSP</a:t>
-            </a:r>
-            <a:endParaRPr lang="en-US" sz="1000" dirty="0"/>
-          </a:p>
-        </p:txBody>
-      </p:sp>
-      <p:sp>
-        <p:nvSpPr>
-          <p:cNvPr id="7" name="Text 5"/>
-          <p:cNvSpPr/>
-          <p:nvPr/>
-        </p:nvSpPr>
-        <p:spPr>
-          <a:xfrm>
-            <a:off x="548640" y="1645920"/>
-            <a:ext cx="9144000" cy="320040"/>
+              <a:t>Taught by</a:t>
+            </a:r>
+            <a:endParaRPr lang="en-US" sz="1100" dirty="0"/>
+          </a:p>
+        </p:txBody>
+      </p:sp>
+      <p:sp>
+        <p:nvSpPr>
+          <p:cNvPr id="12" name="Text 10"/>
+          <p:cNvSpPr/>
+          <p:nvPr/>
+        </p:nvSpPr>
+        <p:spPr>
+          <a:xfrm>
+            <a:off x="548640" y="4434840"/>
+            <a:ext cx="10972800" cy="502920"/>
           </a:xfrm>
           <a:prstGeom prst="rect">
             <a:avLst/>
@@ -1319,30 +1460,69 @@
               <a:buNone/>
             </a:pPr>
             <a:r>
-              <a:rPr lang="en-US" sz="1200" b="1" kern="0" spc="600" dirty="0">
-                <a:solidFill>
-                  <a:srgbClr val="22D3EE"/>
+              <a:rPr lang="en-US" sz="2200" b="1" dirty="0">
+                <a:solidFill>
+                  <a:srgbClr val="FFFFFF"/>
+                </a:solidFill>
+                <a:latin typeface="Georgia" pitchFamily="34" charset="0"/>
+                <a:ea typeface="Georgia" pitchFamily="34" charset="-122"/>
+                <a:cs typeface="Georgia" pitchFamily="34" charset="-120"/>
+              </a:rPr>
+              <a:t>Pr. Ismail Bouishak &amp; Pr. Zouhair El Hadiq</a:t>
+            </a:r>
+            <a:endParaRPr lang="en-US" sz="2200" dirty="0"/>
+          </a:p>
+        </p:txBody>
+      </p:sp>
+      <p:sp>
+        <p:nvSpPr>
+          <p:cNvPr id="13" name="Text 11"/>
+          <p:cNvSpPr/>
+          <p:nvPr/>
+        </p:nvSpPr>
+        <p:spPr>
+          <a:xfrm>
+            <a:off x="548640" y="4956048"/>
+            <a:ext cx="10972800" cy="365760"/>
+          </a:xfrm>
+          <a:prstGeom prst="rect">
+            <a:avLst/>
+          </a:prstGeom>
+          <a:noFill/>
+          <a:ln/>
+        </p:spPr>
+        <p:txBody>
+          <a:bodyPr wrap="square" lIns="0" tIns="0" rIns="0" bIns="0" rtlCol="0" anchor="ctr"/>
+          <a:lstStyle/>
+          <a:p>
+            <a:pPr marL="0" indent="0">
+              <a:buNone/>
+            </a:pPr>
+            <a:r>
+              <a:rPr lang="en-US" sz="1300" i="1" dirty="0">
+                <a:solidFill>
+                  <a:srgbClr val="94A3B8"/>
                 </a:solidFill>
                 <a:latin typeface="Calibri" pitchFamily="34" charset="0"/>
                 <a:ea typeface="Calibri" pitchFamily="34" charset="-122"/>
                 <a:cs typeface="Calibri" pitchFamily="34" charset="-120"/>
               </a:rPr>
-              <a:t>FIRST-MEETING ORIENTATION</a:t>
-            </a:r>
-            <a:endParaRPr lang="en-US" sz="1200" dirty="0"/>
-          </a:p>
-        </p:txBody>
-      </p:sp>
-      <p:sp>
-        <p:nvSpPr>
-          <p:cNvPr id="8" name="Text 6"/>
-          <p:cNvSpPr/>
-          <p:nvPr/>
-        </p:nvSpPr>
-        <p:spPr>
-          <a:xfrm>
-            <a:off x="548640" y="2011680"/>
-            <a:ext cx="10972800" cy="1188720"/>
+              <a:t>Professors of Mathematics &amp; Computer Science</a:t>
+            </a:r>
+            <a:endParaRPr lang="en-US" sz="1300" dirty="0"/>
+          </a:p>
+        </p:txBody>
+      </p:sp>
+      <p:sp>
+        <p:nvSpPr>
+          <p:cNvPr id="14" name="Text 12"/>
+          <p:cNvSpPr/>
+          <p:nvPr/>
+        </p:nvSpPr>
+        <p:spPr>
+          <a:xfrm>
+            <a:off x="548640" y="6126480"/>
+            <a:ext cx="10972800" cy="365760"/>
           </a:xfrm>
           <a:prstGeom prst="rect">
             <a:avLst/>
@@ -1358,235 +1538,86 @@
               <a:buNone/>
             </a:pPr>
             <a:r>
-              <a:rPr lang="en-US" sz="6400" b="1" dirty="0">
-                <a:solidFill>
-                  <a:srgbClr val="FFFFFF"/>
-                </a:solidFill>
-                <a:latin typeface="Georgia" pitchFamily="34" charset="0"/>
-                <a:ea typeface="Georgia" pitchFamily="34" charset="-122"/>
-                <a:cs typeface="Georgia" pitchFamily="34" charset="-120"/>
-              </a:rPr>
-              <a:t>Discrete Mathematics</a:t>
-            </a:r>
-            <a:endParaRPr lang="en-US" sz="6400" dirty="0"/>
-          </a:p>
-        </p:txBody>
-      </p:sp>
-      <p:sp>
-        <p:nvSpPr>
-          <p:cNvPr id="9" name="Text 7"/>
-          <p:cNvSpPr/>
-          <p:nvPr/>
-        </p:nvSpPr>
-        <p:spPr>
-          <a:xfrm>
-            <a:off x="548640" y="3154680"/>
-            <a:ext cx="10972800" cy="548640"/>
-          </a:xfrm>
-          <a:prstGeom prst="rect">
-            <a:avLst/>
-          </a:prstGeom>
-          <a:noFill/>
-          <a:ln/>
-        </p:spPr>
-        <p:txBody>
-          <a:bodyPr wrap="square" lIns="0" tIns="0" rIns="0" bIns="0" rtlCol="0" anchor="ctr"/>
-          <a:lstStyle/>
-          <a:p>
-            <a:pPr marL="0" indent="0">
-              <a:buNone/>
-            </a:pPr>
-            <a:r>
-              <a:rPr lang="en-US" sz="2600" i="1" dirty="0">
-                <a:solidFill>
-                  <a:srgbClr val="22D3EE"/>
-                </a:solidFill>
-                <a:latin typeface="Georgia" pitchFamily="34" charset="0"/>
-                <a:ea typeface="Georgia" pitchFamily="34" charset="-122"/>
-                <a:cs typeface="Georgia" pitchFamily="34" charset="-120"/>
-              </a:rPr>
-              <a:t>Foundations for Computer Science</a:t>
-            </a:r>
-            <a:endParaRPr lang="en-US" sz="2600" dirty="0"/>
-          </a:p>
-        </p:txBody>
-      </p:sp>
-      <p:sp>
-        <p:nvSpPr>
-          <p:cNvPr id="10" name="Shape 8"/>
-          <p:cNvSpPr/>
-          <p:nvPr/>
-        </p:nvSpPr>
-        <p:spPr>
-          <a:xfrm>
-            <a:off x="548640" y="4023360"/>
-            <a:ext cx="731520" cy="45720"/>
-          </a:xfrm>
-          <a:prstGeom prst="rect">
-            <a:avLst/>
-          </a:prstGeom>
-          <a:solidFill>
-            <a:srgbClr val="F59E0B"/>
-          </a:solidFill>
-          <a:ln/>
-        </p:spPr>
-      </p:sp>
-      <p:sp>
-        <p:nvSpPr>
-          <p:cNvPr id="11" name="Text 9"/>
-          <p:cNvSpPr/>
-          <p:nvPr/>
-        </p:nvSpPr>
-        <p:spPr>
-          <a:xfrm>
-            <a:off x="548640" y="4160520"/>
-            <a:ext cx="3657600" cy="274320"/>
-          </a:xfrm>
-          <a:prstGeom prst="rect">
-            <a:avLst/>
-          </a:prstGeom>
-          <a:noFill/>
-          <a:ln/>
-        </p:spPr>
-        <p:txBody>
-          <a:bodyPr wrap="square" lIns="0" tIns="0" rIns="0" bIns="0" rtlCol="0" anchor="ctr"/>
-          <a:lstStyle/>
-          <a:p>
-            <a:pPr marL="0" indent="0">
-              <a:buNone/>
-            </a:pPr>
-            <a:r>
-              <a:rPr lang="en-US" sz="1100" b="1" kern="0" spc="400" dirty="0">
-                <a:solidFill>
-                  <a:srgbClr val="64748B"/>
+              <a:rPr lang="en-US" sz="1200" dirty="0">
+                <a:solidFill>
+                  <a:srgbClr val="94A3B8"/>
                 </a:solidFill>
                 <a:latin typeface="Calibri" pitchFamily="34" charset="0"/>
                 <a:ea typeface="Calibri" pitchFamily="34" charset="-122"/>
                 <a:cs typeface="Calibri" pitchFamily="34" charset="-120"/>
               </a:rPr>
-              <a:t>Taught by</a:t>
-            </a:r>
-            <a:endParaRPr lang="en-US" sz="1100" dirty="0"/>
-          </a:p>
-        </p:txBody>
-      </p:sp>
-      <p:sp>
-        <p:nvSpPr>
-          <p:cNvPr id="12" name="Text 10"/>
-          <p:cNvSpPr/>
-          <p:nvPr/>
-        </p:nvSpPr>
-        <p:spPr>
-          <a:xfrm>
-            <a:off x="548640" y="4434840"/>
-            <a:ext cx="10972800" cy="502920"/>
-          </a:xfrm>
-          <a:prstGeom prst="rect">
-            <a:avLst/>
-          </a:prstGeom>
-          <a:noFill/>
-          <a:ln/>
-        </p:spPr>
-        <p:txBody>
-          <a:bodyPr wrap="square" lIns="0" tIns="0" rIns="0" bIns="0" rtlCol="0" anchor="ctr"/>
-          <a:lstStyle/>
-          <a:p>
-            <a:pPr marL="0" indent="0">
-              <a:buNone/>
-            </a:pPr>
-            <a:r>
-              <a:rPr lang="en-US" sz="2200" b="1" dirty="0">
-                <a:solidFill>
-                  <a:srgbClr val="FFFFFF"/>
-                </a:solidFill>
-                <a:latin typeface="Georgia" pitchFamily="34" charset="0"/>
-                <a:ea typeface="Georgia" pitchFamily="34" charset="-122"/>
-                <a:cs typeface="Georgia" pitchFamily="34" charset="-120"/>
-              </a:rPr>
-              <a:t>Iismail Bouiishak· Zouhair El Hadiq</a:t>
-            </a:r>
-            <a:endParaRPr lang="en-US" sz="2200" dirty="0"/>
-          </a:p>
-        </p:txBody>
-      </p:sp>
-      <p:sp>
-        <p:nvSpPr>
-          <p:cNvPr id="13" name="Text 11"/>
-          <p:cNvSpPr/>
-          <p:nvPr/>
-        </p:nvSpPr>
-        <p:spPr>
-          <a:xfrm>
-            <a:off x="548640" y="4956048"/>
-            <a:ext cx="10972800" cy="365760"/>
-          </a:xfrm>
-          <a:prstGeom prst="rect">
-            <a:avLst/>
-          </a:prstGeom>
-          <a:noFill/>
-          <a:ln/>
-        </p:spPr>
-        <p:txBody>
-          <a:bodyPr wrap="square" lIns="0" tIns="0" rIns="0" bIns="0" rtlCol="0" anchor="ctr"/>
-          <a:lstStyle/>
-          <a:p>
-            <a:pPr marL="0" indent="0">
-              <a:buNone/>
-            </a:pPr>
-            <a:r>
-              <a:rPr lang="en-US" sz="1300" i="1" dirty="0">
-                <a:solidFill>
-                  <a:srgbClr val="94A3B8"/>
-                </a:solidFill>
-                <a:latin typeface="Calibri" pitchFamily="34" charset="0"/>
-                <a:ea typeface="Calibri" pitchFamily="34" charset="-122"/>
-                <a:cs typeface="Calibri" pitchFamily="34" charset="-120"/>
-              </a:rPr>
-              <a:t>Professors of Mathematics &amp; Computer Science</a:t>
-            </a:r>
-            <a:endParaRPr lang="en-US" sz="1300" dirty="0"/>
-          </a:p>
-        </p:txBody>
-      </p:sp>
-      <p:sp>
-        <p:nvSpPr>
-          <p:cNvPr id="14" name="Text 12"/>
-          <p:cNvSpPr/>
-          <p:nvPr/>
-        </p:nvSpPr>
-        <p:spPr>
-          <a:xfrm>
-            <a:off x="548640" y="6126480"/>
-            <a:ext cx="10972800" cy="365760"/>
-          </a:xfrm>
-          <a:prstGeom prst="rect">
-            <a:avLst/>
-          </a:prstGeom>
-          <a:noFill/>
-          <a:ln/>
-        </p:spPr>
-        <p:txBody>
-          <a:bodyPr wrap="square" lIns="0" tIns="0" rIns="0" bIns="0" rtlCol="0" anchor="ctr"/>
-          <a:lstStyle/>
-          <a:p>
-            <a:pPr marL="0" indent="0">
-              <a:buNone/>
-            </a:pPr>
-            <a:r>
-              <a:rPr lang="en-US" sz="1200" dirty="0">
-                <a:solidFill>
-                  <a:srgbClr val="94A3B8"/>
-                </a:solidFill>
-                <a:latin typeface="Calibri" pitchFamily="34" charset="0"/>
-                <a:ea typeface="Calibri" pitchFamily="34" charset="-122"/>
-                <a:cs typeface="Calibri" pitchFamily="34" charset="-120"/>
-              </a:rPr>
               <a:t>Welcome — let's set the stage for the semester.</a:t>
             </a:r>
             <a:endParaRPr lang="en-US" sz="1200" dirty="0"/>
           </a:p>
         </p:txBody>
       </p:sp>
+      <p:pic>
+        <p:nvPicPr>
+          <p:cNvPr id="18" name="Image 17">
+            <a:extLst>
+              <a:ext uri="{FF2B5EF4-FFF2-40B4-BE49-F238E27FC236}">
+                <a16:creationId xmlns:a16="http://schemas.microsoft.com/office/drawing/2014/main" id="{4E21E16F-87FB-9349-1F10-B43998F2CE93}"/>
+              </a:ext>
+            </a:extLst>
+          </p:cNvPr>
+          <p:cNvPicPr>
+            <a:picLocks noChangeAspect="1"/>
+          </p:cNvPicPr>
+          <p:nvPr/>
+        </p:nvPicPr>
+        <p:blipFill>
+          <a:blip r:embed="rId3"/>
+          <a:stretch>
+            <a:fillRect/>
+          </a:stretch>
+        </p:blipFill>
+        <p:spPr>
+          <a:xfrm>
+            <a:off x="6705600" y="2899611"/>
+            <a:ext cx="4937760" cy="3291840"/>
+          </a:xfrm>
+          <a:prstGeom prst="rect">
+            <a:avLst/>
+          </a:prstGeom>
+        </p:spPr>
+      </p:pic>
+      <p:pic>
+        <p:nvPicPr>
+          <p:cNvPr id="20" name="Graphique 19">
+            <a:extLst>
+              <a:ext uri="{FF2B5EF4-FFF2-40B4-BE49-F238E27FC236}">
+                <a16:creationId xmlns:a16="http://schemas.microsoft.com/office/drawing/2014/main" id="{E4CB8103-F97B-D88A-D417-F83BA9577209}"/>
+              </a:ext>
+            </a:extLst>
+          </p:cNvPr>
+          <p:cNvPicPr>
+            <a:picLocks noChangeAspect="1"/>
+          </p:cNvPicPr>
+          <p:nvPr/>
+        </p:nvPicPr>
+        <p:blipFill>
+          <a:blip>
+            <a:extLst>
+              <a:ext uri="{96DAC541-7B7A-43D3-8B79-37D633B846F1}">
+                <asvg:svgBlip xmlns:asvg="http://schemas.microsoft.com/office/drawing/2016/SVG/main" r:embed="rId4"/>
+              </a:ext>
+            </a:extLst>
+          </a:blip>
+          <a:stretch>
+            <a:fillRect/>
+          </a:stretch>
+        </p:blipFill>
+        <p:spPr>
+          <a:xfrm>
+            <a:off x="4206240" y="199148"/>
+            <a:ext cx="3051710" cy="1044436"/>
+          </a:xfrm>
+          <a:prstGeom prst="rect">
+            <a:avLst/>
+          </a:prstGeom>
+        </p:spPr>
+      </p:pic>
     </p:spTree>
   </p:cSld>
   <p:clrMapOvr>
@@ -1722,6 +1753,13 @@
             <a:prstDash val="solid"/>
           </a:ln>
         </p:spPr>
+        <p:txBody>
+          <a:bodyPr/>
+          <a:lstStyle/>
+          <a:p>
+            <a:endParaRPr lang="fr-MA"/>
+          </a:p>
+        </p:txBody>
       </p:sp>
       <p:sp>
         <p:nvSpPr>
@@ -1742,6 +1780,13 @@
           </a:solidFill>
           <a:ln/>
         </p:spPr>
+        <p:txBody>
+          <a:bodyPr/>
+          <a:lstStyle/>
+          <a:p>
+            <a:endParaRPr lang="fr-MA"/>
+          </a:p>
+        </p:txBody>
       </p:sp>
       <p:sp>
         <p:nvSpPr>
@@ -1757,36 +1802,29 @@
           <a:prstGeom prst="ellipse">
             <a:avLst/>
           </a:prstGeom>
-          <a:solidFill>
-            <a:srgbClr val="0E7490"/>
-          </a:solidFill>
-          <a:ln/>
-        </p:spPr>
-      </p:sp>
-      <p:pic>
-        <p:nvPicPr>
-          <p:cNvPr id="7" name="Image 0" descr="preencoded.png"/>
-          <p:cNvPicPr>
-            <a:picLocks noChangeAspect="1"/>
-          </p:cNvPicPr>
-          <p:nvPr/>
-        </p:nvPicPr>
-        <p:blipFill>
-          <a:blip r:embed="rId3"/>
-          <a:stretch>
-            <a:fillRect/>
-          </a:stretch>
-        </p:blipFill>
-        <p:spPr>
-          <a:xfrm>
-            <a:off x="1188720" y="2468880"/>
-            <a:ext cx="457200" cy="457200"/>
-          </a:xfrm>
-          <a:prstGeom prst="rect">
-            <a:avLst/>
-          </a:prstGeom>
-        </p:spPr>
-      </p:pic>
+          <a:blipFill dpi="0" rotWithShape="1">
+            <a:blip r:embed="rId3">
+              <a:extLst>
+                <a:ext uri="{28A0092B-C50C-407E-A947-70E740481C1C}">
+                  <a14:useLocalDpi xmlns:a14="http://schemas.microsoft.com/office/drawing/2010/main" val="0"/>
+                </a:ext>
+              </a:extLst>
+            </a:blip>
+            <a:srcRect/>
+            <a:stretch>
+              <a:fillRect/>
+            </a:stretch>
+          </a:blipFill>
+          <a:ln/>
+        </p:spPr>
+        <p:txBody>
+          <a:bodyPr/>
+          <a:lstStyle/>
+          <a:p>
+            <a:endParaRPr lang="fr-MA"/>
+          </a:p>
+        </p:txBody>
+      </p:sp>
       <p:sp>
         <p:nvSpPr>
           <p:cNvPr id="8" name="Text 5"/>
@@ -1859,7 +1897,7 @@
                 <a:ea typeface="Calibri" pitchFamily="34" charset="-122"/>
                 <a:cs typeface="Calibri" pitchFamily="34" charset="-120"/>
               </a:rPr>
-              <a:t>Professor — Discrete Math &amp; CS</a:t>
+              <a:t>Professor — Discrete Math</a:t>
             </a:r>
             <a:endParaRPr lang="en-US" sz="1200" dirty="0"/>
           </a:p>
@@ -1887,6 +1925,13 @@
             <a:prstDash val="solid"/>
           </a:ln>
         </p:spPr>
+        <p:txBody>
+          <a:bodyPr/>
+          <a:lstStyle/>
+          <a:p>
+            <a:endParaRPr lang="fr-MA"/>
+          </a:p>
+        </p:txBody>
       </p:sp>
       <p:sp>
         <p:nvSpPr>
@@ -1925,7 +1970,7 @@
                 <a:ea typeface="Calibri" pitchFamily="34" charset="-122"/>
                 <a:cs typeface="Calibri" pitchFamily="34" charset="-120"/>
               </a:rPr>
-              <a:t>Teaching foundations of computing</a:t>
+              <a:t>Professor Agrégé In Mathematics</a:t>
             </a:r>
             <a:endParaRPr lang="en-US" sz="1400" dirty="0"/>
           </a:p>
@@ -1946,7 +1991,7 @@
                 <a:ea typeface="Calibri" pitchFamily="34" charset="-122"/>
                 <a:cs typeface="Calibri" pitchFamily="34" charset="-120"/>
               </a:rPr>
-              <a:t>Interests: logic, combinatorics, algorithms</a:t>
+              <a:t>Process Engineer of ENIM</a:t>
             </a:r>
             <a:endParaRPr lang="en-US" sz="1400" dirty="0"/>
           </a:p>
@@ -1967,8 +2012,44 @@
                 <a:ea typeface="Calibri" pitchFamily="34" charset="-122"/>
                 <a:cs typeface="Calibri" pitchFamily="34" charset="-120"/>
               </a:rPr>
-              <a:t>Email: zouhairelhadiq@gmail.com</a:t>
-            </a:r>
+              <a:t>Experiences in Mathematics teaching @ CPGE</a:t>
+            </a:r>
+          </a:p>
+          <a:p>
+            <a:pPr marL="342900" indent="-342900">
+              <a:spcAft>
+                <a:spcPts val="600"/>
+              </a:spcAft>
+              <a:buSzPct val="100000"/>
+              <a:buChar char="■"/>
+            </a:pPr>
+            <a:r>
+              <a:rPr lang="fr-MA" sz="1400" dirty="0">
+                <a:solidFill>
+                  <a:srgbClr val="1E293B"/>
+                </a:solidFill>
+                <a:latin typeface="Calibri" pitchFamily="34" charset="0"/>
+                <a:ea typeface="Calibri" pitchFamily="34" charset="-122"/>
+                <a:cs typeface="Calibri" pitchFamily="34" charset="-120"/>
+              </a:rPr>
+              <a:t>Ismail.BOUISHAK@um6p.ma</a:t>
+            </a:r>
+            <a:endParaRPr lang="en-US" sz="1400" dirty="0">
+              <a:solidFill>
+                <a:srgbClr val="1E293B"/>
+              </a:solidFill>
+              <a:latin typeface="Calibri" pitchFamily="34" charset="0"/>
+              <a:ea typeface="Calibri" pitchFamily="34" charset="-122"/>
+              <a:cs typeface="Calibri" pitchFamily="34" charset="-120"/>
+            </a:endParaRPr>
+          </a:p>
+          <a:p>
+            <a:pPr>
+              <a:spcAft>
+                <a:spcPts val="600"/>
+              </a:spcAft>
+              <a:buSzPct val="100000"/>
+            </a:pPr>
             <a:endParaRPr lang="en-US" sz="1400" dirty="0"/>
           </a:p>
         </p:txBody>
@@ -1997,6 +2078,13 @@
             <a:prstDash val="solid"/>
           </a:ln>
         </p:spPr>
+        <p:txBody>
+          <a:bodyPr/>
+          <a:lstStyle/>
+          <a:p>
+            <a:endParaRPr lang="fr-MA"/>
+          </a:p>
+        </p:txBody>
       </p:sp>
       <p:sp>
         <p:nvSpPr>
@@ -2017,6 +2105,13 @@
           </a:solidFill>
           <a:ln/>
         </p:spPr>
+        <p:txBody>
+          <a:bodyPr/>
+          <a:lstStyle/>
+          <a:p>
+            <a:endParaRPr lang="fr-MA"/>
+          </a:p>
+        </p:txBody>
       </p:sp>
       <p:sp>
         <p:nvSpPr>
@@ -2032,36 +2127,29 @@
           <a:prstGeom prst="ellipse">
             <a:avLst/>
           </a:prstGeom>
-          <a:solidFill>
-            <a:srgbClr val="0E7490"/>
-          </a:solidFill>
-          <a:ln/>
-        </p:spPr>
-      </p:sp>
-      <p:pic>
-        <p:nvPicPr>
-          <p:cNvPr id="15" name="Image 1" descr="preencoded.png"/>
-          <p:cNvPicPr>
-            <a:picLocks noChangeAspect="1"/>
-          </p:cNvPicPr>
-          <p:nvPr/>
-        </p:nvPicPr>
-        <p:blipFill>
-          <a:blip r:embed="rId4"/>
-          <a:stretch>
-            <a:fillRect/>
-          </a:stretch>
-        </p:blipFill>
-        <p:spPr>
-          <a:xfrm>
-            <a:off x="6995160" y="2468880"/>
-            <a:ext cx="457200" cy="457200"/>
-          </a:xfrm>
-          <a:prstGeom prst="rect">
-            <a:avLst/>
-          </a:prstGeom>
-        </p:spPr>
-      </p:pic>
+          <a:blipFill dpi="0" rotWithShape="1">
+            <a:blip r:embed="rId4">
+              <a:extLst>
+                <a:ext uri="{28A0092B-C50C-407E-A947-70E740481C1C}">
+                  <a14:useLocalDpi xmlns:a14="http://schemas.microsoft.com/office/drawing/2010/main" val="0"/>
+                </a:ext>
+              </a:extLst>
+            </a:blip>
+            <a:srcRect/>
+            <a:stretch>
+              <a:fillRect/>
+            </a:stretch>
+          </a:blipFill>
+          <a:ln/>
+        </p:spPr>
+        <p:txBody>
+          <a:bodyPr/>
+          <a:lstStyle/>
+          <a:p>
+            <a:endParaRPr lang="fr-MA"/>
+          </a:p>
+        </p:txBody>
+      </p:sp>
       <p:sp>
         <p:nvSpPr>
           <p:cNvPr id="16" name="Text 12"/>
@@ -2132,7 +2220,7 @@
                 <a:ea typeface="Calibri" pitchFamily="34" charset="-122"/>
                 <a:cs typeface="Calibri" pitchFamily="34" charset="-120"/>
               </a:rPr>
-              <a:t>Professor — Discrete Math &amp; CS</a:t>
+              <a:t>Professor — CS &amp; Discrete Math</a:t>
             </a:r>
             <a:endParaRPr lang="en-US" sz="1200" dirty="0"/>
           </a:p>
@@ -2160,6 +2248,13 @@
             <a:prstDash val="solid"/>
           </a:ln>
         </p:spPr>
+        <p:txBody>
+          <a:bodyPr/>
+          <a:lstStyle/>
+          <a:p>
+            <a:endParaRPr lang="fr-MA"/>
+          </a:p>
+        </p:txBody>
       </p:sp>
       <p:sp>
         <p:nvSpPr>
@@ -2198,7 +2293,7 @@
                 <a:ea typeface="Calibri" pitchFamily="34" charset="-122"/>
                 <a:cs typeface="Calibri" pitchFamily="34" charset="-120"/>
               </a:rPr>
-              <a:t>Teaching foundations of computing</a:t>
+              <a:t>Professor Agrégé In Computer Science</a:t>
             </a:r>
             <a:endParaRPr lang="en-US" sz="1400" dirty="0"/>
           </a:p>
@@ -2219,9 +2314,8 @@
                 <a:ea typeface="Calibri" pitchFamily="34" charset="-122"/>
                 <a:cs typeface="Calibri" pitchFamily="34" charset="-120"/>
               </a:rPr>
-              <a:t>Interests: graph theory, formal methods</a:t>
-            </a:r>
-            <a:endParaRPr lang="en-US" sz="1400" dirty="0"/>
+              <a:t>Modeling And Scientific computer engineer of  EMI.</a:t>
+            </a:r>
           </a:p>
           <a:p>
             <a:pPr marL="342900" indent="-342900">
@@ -2240,8 +2334,37 @@
                 <a:ea typeface="Calibri" pitchFamily="34" charset="-122"/>
                 <a:cs typeface="Calibri" pitchFamily="34" charset="-120"/>
               </a:rPr>
-              <a:t>Co-instructor for this module</a:t>
-            </a:r>
+              <a:t>Experiences in computer science teaching @ CPGE</a:t>
+            </a:r>
+          </a:p>
+          <a:p>
+            <a:pPr marL="342900" indent="-342900">
+              <a:spcAft>
+                <a:spcPts val="600"/>
+              </a:spcAft>
+              <a:buSzPct val="100000"/>
+              <a:buChar char="■"/>
+            </a:pPr>
+            <a:r>
+              <a:rPr lang="en-US" sz="1400" dirty="0">
+                <a:solidFill>
+                  <a:srgbClr val="1E293B"/>
+                </a:solidFill>
+                <a:latin typeface="Calibri" pitchFamily="34" charset="0"/>
+                <a:ea typeface="Calibri" pitchFamily="34" charset="-122"/>
+                <a:cs typeface="Calibri" pitchFamily="34" charset="-120"/>
+              </a:rPr>
+              <a:t>zouhairelhadiq@cpgeacademy.org</a:t>
+            </a:r>
+          </a:p>
+          <a:p>
+            <a:pPr marL="342900" indent="-342900">
+              <a:spcAft>
+                <a:spcPts val="600"/>
+              </a:spcAft>
+              <a:buSzPct val="100000"/>
+              <a:buChar char="■"/>
+            </a:pPr>
             <a:endParaRPr lang="en-US" sz="1400" dirty="0"/>
           </a:p>
         </p:txBody>
@@ -2265,6 +2388,13 @@
           </a:solidFill>
           <a:ln/>
         </p:spPr>
+        <p:txBody>
+          <a:bodyPr/>
+          <a:lstStyle/>
+          <a:p>
+            <a:endParaRPr lang="fr-MA"/>
+          </a:p>
+        </p:txBody>
       </p:sp>
       <p:sp>
         <p:nvSpPr>
@@ -2327,6 +2457,13 @@
             <a:prstDash val="solid"/>
           </a:ln>
         </p:spPr>
+        <p:txBody>
+          <a:bodyPr/>
+          <a:lstStyle/>
+          <a:p>
+            <a:endParaRPr lang="fr-MA"/>
+          </a:p>
+        </p:txBody>
       </p:sp>
       <p:sp>
         <p:nvSpPr>
@@ -2361,7 +2498,29 @@
                 <a:ea typeface="Calibri" pitchFamily="34" charset="-122"/>
                 <a:cs typeface="Calibri" pitchFamily="34" charset="-120"/>
               </a:rPr>
-              <a:t>Discrete Mathematics  ·  DMath_CC_25  ·  ACSP</a:t>
+              <a:t>Discrete Mathematics  ·  </a:t>
+            </a:r>
+            <a:r>
+              <a:rPr lang="en-US" sz="900" dirty="0" err="1">
+                <a:solidFill>
+                  <a:srgbClr val="64748B"/>
+                </a:solidFill>
+                <a:latin typeface="Calibri" pitchFamily="34" charset="0"/>
+                <a:ea typeface="Calibri" pitchFamily="34" charset="-122"/>
+                <a:cs typeface="Calibri" pitchFamily="34" charset="-120"/>
+              </a:rPr>
+              <a:t>DMath</a:t>
+            </a:r>
+            <a:r>
+              <a:rPr lang="en-US" sz="900" dirty="0">
+                <a:solidFill>
+                  <a:srgbClr val="64748B"/>
+                </a:solidFill>
+                <a:latin typeface="Calibri" pitchFamily="34" charset="0"/>
+                <a:ea typeface="Calibri" pitchFamily="34" charset="-122"/>
+                <a:cs typeface="Calibri" pitchFamily="34" charset="-120"/>
+              </a:rPr>
+              <a:t>·  ACSP</a:t>
             </a:r>
             <a:endParaRPr lang="en-US" sz="900" dirty="0"/>
           </a:p>
@@ -2587,6 +2746,13 @@
             </a:outerShdw>
           </a:effectLst>
         </p:spPr>
+        <p:txBody>
+          <a:bodyPr/>
+          <a:lstStyle/>
+          <a:p>
+            <a:endParaRPr lang="fr-MA"/>
+          </a:p>
+        </p:txBody>
       </p:sp>
       <p:sp>
         <p:nvSpPr>
@@ -2607,6 +2773,13 @@
           </a:solidFill>
           <a:ln/>
         </p:spPr>
+        <p:txBody>
+          <a:bodyPr/>
+          <a:lstStyle/>
+          <a:p>
+            <a:endParaRPr lang="fr-MA"/>
+          </a:p>
+        </p:txBody>
       </p:sp>
       <p:sp>
         <p:nvSpPr>
@@ -2627,6 +2800,13 @@
           </a:solidFill>
           <a:ln/>
         </p:spPr>
+        <p:txBody>
+          <a:bodyPr/>
+          <a:lstStyle/>
+          <a:p>
+            <a:endParaRPr lang="fr-MA"/>
+          </a:p>
+        </p:txBody>
       </p:sp>
       <p:pic>
         <p:nvPicPr>
@@ -2761,6 +2941,13 @@
             </a:outerShdw>
           </a:effectLst>
         </p:spPr>
+        <p:txBody>
+          <a:bodyPr/>
+          <a:lstStyle/>
+          <a:p>
+            <a:endParaRPr lang="fr-MA"/>
+          </a:p>
+        </p:txBody>
       </p:sp>
       <p:sp>
         <p:nvSpPr>
@@ -2781,6 +2968,13 @@
           </a:solidFill>
           <a:ln/>
         </p:spPr>
+        <p:txBody>
+          <a:bodyPr/>
+          <a:lstStyle/>
+          <a:p>
+            <a:endParaRPr lang="fr-MA"/>
+          </a:p>
+        </p:txBody>
       </p:sp>
       <p:sp>
         <p:nvSpPr>
@@ -2801,6 +2995,13 @@
           </a:solidFill>
           <a:ln/>
         </p:spPr>
+        <p:txBody>
+          <a:bodyPr/>
+          <a:lstStyle/>
+          <a:p>
+            <a:endParaRPr lang="fr-MA"/>
+          </a:p>
+        </p:txBody>
       </p:sp>
       <p:pic>
         <p:nvPicPr>
@@ -2898,7 +3099,7 @@
                 <a:ea typeface="Calibri" pitchFamily="34" charset="-122"/>
                 <a:cs typeface="Calibri" pitchFamily="34" charset="-120"/>
               </a:rPr>
-              <a:t>Boolean logic powers circuits, proofs, and program correctness.</a:t>
+              <a:t>Boolean logic powers circuits and proofs.</a:t>
             </a:r>
             <a:endParaRPr lang="en-US" sz="1300" dirty="0"/>
           </a:p>
@@ -2935,6 +3136,13 @@
             </a:outerShdw>
           </a:effectLst>
         </p:spPr>
+        <p:txBody>
+          <a:bodyPr/>
+          <a:lstStyle/>
+          <a:p>
+            <a:endParaRPr lang="fr-MA"/>
+          </a:p>
+        </p:txBody>
       </p:sp>
       <p:sp>
         <p:nvSpPr>
@@ -2955,6 +3163,13 @@
           </a:solidFill>
           <a:ln/>
         </p:spPr>
+        <p:txBody>
+          <a:bodyPr/>
+          <a:lstStyle/>
+          <a:p>
+            <a:endParaRPr lang="fr-MA"/>
+          </a:p>
+        </p:txBody>
       </p:sp>
       <p:sp>
         <p:nvSpPr>
@@ -2975,6 +3190,13 @@
           </a:solidFill>
           <a:ln/>
         </p:spPr>
+        <p:txBody>
+          <a:bodyPr/>
+          <a:lstStyle/>
+          <a:p>
+            <a:endParaRPr lang="fr-MA"/>
+          </a:p>
+        </p:txBody>
       </p:sp>
       <p:pic>
         <p:nvPicPr>
@@ -3109,6 +3331,13 @@
             </a:outerShdw>
           </a:effectLst>
         </p:spPr>
+        <p:txBody>
+          <a:bodyPr/>
+          <a:lstStyle/>
+          <a:p>
+            <a:endParaRPr lang="fr-MA"/>
+          </a:p>
+        </p:txBody>
       </p:sp>
       <p:sp>
         <p:nvSpPr>
@@ -3129,6 +3358,13 @@
           </a:solidFill>
           <a:ln/>
         </p:spPr>
+        <p:txBody>
+          <a:bodyPr/>
+          <a:lstStyle/>
+          <a:p>
+            <a:endParaRPr lang="fr-MA"/>
+          </a:p>
+        </p:txBody>
       </p:sp>
       <p:sp>
         <p:nvSpPr>
@@ -3149,6 +3385,13 @@
           </a:solidFill>
           <a:ln/>
         </p:spPr>
+        <p:txBody>
+          <a:bodyPr/>
+          <a:lstStyle/>
+          <a:p>
+            <a:endParaRPr lang="fr-MA"/>
+          </a:p>
+        </p:txBody>
       </p:sp>
       <p:pic>
         <p:nvPicPr>
@@ -3274,6 +3517,13 @@
             <a:prstDash val="solid"/>
           </a:ln>
         </p:spPr>
+        <p:txBody>
+          <a:bodyPr/>
+          <a:lstStyle/>
+          <a:p>
+            <a:endParaRPr lang="fr-MA"/>
+          </a:p>
+        </p:txBody>
       </p:sp>
       <p:sp>
         <p:nvSpPr>
@@ -3308,7 +3558,29 @@
                 <a:ea typeface="Calibri" pitchFamily="34" charset="-122"/>
                 <a:cs typeface="Calibri" pitchFamily="34" charset="-120"/>
               </a:rPr>
-              <a:t>Discrete Mathematics  ·  DMath_CC_25  ·  ACSP</a:t>
+              <a:t>Discrete Mathematics  ·  </a:t>
+            </a:r>
+            <a:r>
+              <a:rPr lang="en-US" sz="900" dirty="0" err="1">
+                <a:solidFill>
+                  <a:srgbClr val="64748B"/>
+                </a:solidFill>
+                <a:latin typeface="Calibri" pitchFamily="34" charset="0"/>
+                <a:ea typeface="Calibri" pitchFamily="34" charset="-122"/>
+                <a:cs typeface="Calibri" pitchFamily="34" charset="-120"/>
+              </a:rPr>
+              <a:t>DMath</a:t>
+            </a:r>
+            <a:r>
+              <a:rPr lang="en-US" sz="900" dirty="0">
+                <a:solidFill>
+                  <a:srgbClr val="64748B"/>
+                </a:solidFill>
+                <a:latin typeface="Calibri" pitchFamily="34" charset="0"/>
+                <a:ea typeface="Calibri" pitchFamily="34" charset="-122"/>
+                <a:cs typeface="Calibri" pitchFamily="34" charset="-120"/>
+              </a:rPr>
+              <a:t>  ·  ACSP</a:t>
             </a:r>
             <a:endParaRPr lang="en-US" sz="900" dirty="0"/>
           </a:p>
@@ -3419,7 +3691,18 @@
                 <a:ea typeface="Calibri" pitchFamily="34" charset="-122"/>
                 <a:cs typeface="Calibri" pitchFamily="34" charset="-120"/>
               </a:rPr>
-              <a:t>MODULE ROADMAP — DMath_CC_25</a:t>
+              <a:t>MODULE ROADMAP — </a:t>
+            </a:r>
+            <a:r>
+              <a:rPr lang="en-US" sz="1100" b="1" kern="0" spc="400" dirty="0" err="1">
+                <a:solidFill>
+                  <a:srgbClr val="0E7490"/>
+                </a:solidFill>
+                <a:latin typeface="Calibri" pitchFamily="34" charset="0"/>
+                <a:ea typeface="Calibri" pitchFamily="34" charset="-122"/>
+                <a:cs typeface="Calibri" pitchFamily="34" charset="-120"/>
+              </a:rPr>
+              <a:t>DMath</a:t>
             </a:r>
             <a:endParaRPr lang="en-US" sz="1100" dirty="0"/>
           </a:p>
@@ -3433,7 +3716,7 @@
         </p:nvSpPr>
         <p:spPr>
           <a:xfrm>
-            <a:off x="548640" y="713232"/>
+            <a:off x="548640" y="777240"/>
             <a:ext cx="10972800" cy="777240"/>
           </a:xfrm>
           <a:prstGeom prst="rect">
@@ -3458,7 +3741,7 @@
                 <a:ea typeface="Georgia" pitchFamily="34" charset="-122"/>
                 <a:cs typeface="Georgia" pitchFamily="34" charset="-120"/>
               </a:rPr>
-              <a:t>Seven sequences across the semester</a:t>
+              <a:t>Seven sequences across the module</a:t>
             </a:r>
             <a:endParaRPr lang="en-US" sz="3600" dirty="0"/>
           </a:p>
@@ -3488,6 +3771,13 @@
             <a:prstDash val="solid"/>
           </a:ln>
         </p:spPr>
+        <p:txBody>
+          <a:bodyPr/>
+          <a:lstStyle/>
+          <a:p>
+            <a:endParaRPr lang="fr-MA"/>
+          </a:p>
+        </p:txBody>
       </p:sp>
       <p:sp>
         <p:nvSpPr>
@@ -3610,6 +3900,13 @@
           </a:solidFill>
           <a:ln/>
         </p:spPr>
+        <p:txBody>
+          <a:bodyPr/>
+          <a:lstStyle/>
+          <a:p>
+            <a:endParaRPr lang="fr-MA"/>
+          </a:p>
+        </p:txBody>
       </p:sp>
       <p:sp>
         <p:nvSpPr>
@@ -3674,6 +3971,13 @@
             <a:prstDash val="solid"/>
           </a:ln>
         </p:spPr>
+        <p:txBody>
+          <a:bodyPr/>
+          <a:lstStyle/>
+          <a:p>
+            <a:endParaRPr lang="fr-MA"/>
+          </a:p>
+        </p:txBody>
       </p:sp>
       <p:sp>
         <p:nvSpPr>
@@ -3796,6 +4100,13 @@
           </a:solidFill>
           <a:ln/>
         </p:spPr>
+        <p:txBody>
+          <a:bodyPr/>
+          <a:lstStyle/>
+          <a:p>
+            <a:endParaRPr lang="fr-MA"/>
+          </a:p>
+        </p:txBody>
       </p:sp>
       <p:sp>
         <p:nvSpPr>
@@ -3860,6 +4171,13 @@
             <a:prstDash val="solid"/>
           </a:ln>
         </p:spPr>
+        <p:txBody>
+          <a:bodyPr/>
+          <a:lstStyle/>
+          <a:p>
+            <a:endParaRPr lang="fr-MA"/>
+          </a:p>
+        </p:txBody>
       </p:sp>
       <p:sp>
         <p:nvSpPr>
@@ -3982,6 +4300,13 @@
           </a:solidFill>
           <a:ln/>
         </p:spPr>
+        <p:txBody>
+          <a:bodyPr/>
+          <a:lstStyle/>
+          <a:p>
+            <a:endParaRPr lang="fr-MA"/>
+          </a:p>
+        </p:txBody>
       </p:sp>
       <p:sp>
         <p:nvSpPr>
@@ -4046,6 +4371,13 @@
             <a:prstDash val="solid"/>
           </a:ln>
         </p:spPr>
+        <p:txBody>
+          <a:bodyPr/>
+          <a:lstStyle/>
+          <a:p>
+            <a:endParaRPr lang="fr-MA"/>
+          </a:p>
+        </p:txBody>
       </p:sp>
       <p:sp>
         <p:nvSpPr>
@@ -4168,6 +4500,13 @@
           </a:solidFill>
           <a:ln/>
         </p:spPr>
+        <p:txBody>
+          <a:bodyPr/>
+          <a:lstStyle/>
+          <a:p>
+            <a:endParaRPr lang="fr-MA"/>
+          </a:p>
+        </p:txBody>
       </p:sp>
       <p:sp>
         <p:nvSpPr>
@@ -4232,6 +4571,13 @@
             <a:prstDash val="solid"/>
           </a:ln>
         </p:spPr>
+        <p:txBody>
+          <a:bodyPr/>
+          <a:lstStyle/>
+          <a:p>
+            <a:endParaRPr lang="fr-MA"/>
+          </a:p>
+        </p:txBody>
       </p:sp>
       <p:sp>
         <p:nvSpPr>
@@ -4354,6 +4700,13 @@
           </a:solidFill>
           <a:ln/>
         </p:spPr>
+        <p:txBody>
+          <a:bodyPr/>
+          <a:lstStyle/>
+          <a:p>
+            <a:endParaRPr lang="fr-MA"/>
+          </a:p>
+        </p:txBody>
       </p:sp>
       <p:sp>
         <p:nvSpPr>
@@ -4418,6 +4771,13 @@
             <a:prstDash val="solid"/>
           </a:ln>
         </p:spPr>
+        <p:txBody>
+          <a:bodyPr/>
+          <a:lstStyle/>
+          <a:p>
+            <a:endParaRPr lang="fr-MA"/>
+          </a:p>
+        </p:txBody>
       </p:sp>
       <p:sp>
         <p:nvSpPr>
@@ -4540,6 +4900,13 @@
           </a:solidFill>
           <a:ln/>
         </p:spPr>
+        <p:txBody>
+          <a:bodyPr/>
+          <a:lstStyle/>
+          <a:p>
+            <a:endParaRPr lang="fr-MA"/>
+          </a:p>
+        </p:txBody>
       </p:sp>
       <p:sp>
         <p:nvSpPr>
@@ -4604,6 +4971,13 @@
             <a:prstDash val="solid"/>
           </a:ln>
         </p:spPr>
+        <p:txBody>
+          <a:bodyPr/>
+          <a:lstStyle/>
+          <a:p>
+            <a:endParaRPr lang="fr-MA"/>
+          </a:p>
+        </p:txBody>
       </p:sp>
       <p:sp>
         <p:nvSpPr>
@@ -4726,6 +5100,13 @@
           </a:solidFill>
           <a:ln/>
         </p:spPr>
+        <p:txBody>
+          <a:bodyPr/>
+          <a:lstStyle/>
+          <a:p>
+            <a:endParaRPr lang="fr-MA"/>
+          </a:p>
+        </p:txBody>
       </p:sp>
       <p:sp>
         <p:nvSpPr>
@@ -4788,6 +5169,13 @@
             <a:prstDash val="solid"/>
           </a:ln>
         </p:spPr>
+        <p:txBody>
+          <a:bodyPr/>
+          <a:lstStyle/>
+          <a:p>
+            <a:endParaRPr lang="fr-MA"/>
+          </a:p>
+        </p:txBody>
       </p:sp>
       <p:sp>
         <p:nvSpPr>
@@ -4822,7 +5210,29 @@
                 <a:ea typeface="Calibri" pitchFamily="34" charset="-122"/>
                 <a:cs typeface="Calibri" pitchFamily="34" charset="-120"/>
               </a:rPr>
-              <a:t>Discrete Mathematics  ·  DMath_CC_25  ·  ACSP</a:t>
+              <a:t>Discrete Mathematics  ·  </a:t>
+            </a:r>
+            <a:r>
+              <a:rPr lang="en-US" sz="900" dirty="0" err="1">
+                <a:solidFill>
+                  <a:srgbClr val="64748B"/>
+                </a:solidFill>
+                <a:latin typeface="Calibri" pitchFamily="34" charset="0"/>
+                <a:ea typeface="Calibri" pitchFamily="34" charset="-122"/>
+                <a:cs typeface="Calibri" pitchFamily="34" charset="-120"/>
+              </a:rPr>
+              <a:t>DMath</a:t>
+            </a:r>
+            <a:r>
+              <a:rPr lang="en-US" sz="900" dirty="0">
+                <a:solidFill>
+                  <a:srgbClr val="64748B"/>
+                </a:solidFill>
+                <a:latin typeface="Calibri" pitchFamily="34" charset="0"/>
+                <a:ea typeface="Calibri" pitchFamily="34" charset="-122"/>
+                <a:cs typeface="Calibri" pitchFamily="34" charset="-120"/>
+              </a:rPr>
+              <a:t>  ·  ACSP</a:t>
             </a:r>
             <a:endParaRPr lang="en-US" sz="900" dirty="0"/>
           </a:p>
@@ -5048,6 +5458,13 @@
             </a:outerShdw>
           </a:effectLst>
         </p:spPr>
+        <p:txBody>
+          <a:bodyPr/>
+          <a:lstStyle/>
+          <a:p>
+            <a:endParaRPr lang="fr-MA"/>
+          </a:p>
+        </p:txBody>
       </p:sp>
       <p:sp>
         <p:nvSpPr>
@@ -5068,6 +5485,13 @@
           </a:solidFill>
           <a:ln/>
         </p:spPr>
+        <p:txBody>
+          <a:bodyPr/>
+          <a:lstStyle/>
+          <a:p>
+            <a:endParaRPr lang="fr-MA"/>
+          </a:p>
+        </p:txBody>
       </p:sp>
       <p:pic>
         <p:nvPicPr>
@@ -5226,6 +5650,13 @@
             </a:outerShdw>
           </a:effectLst>
         </p:spPr>
+        <p:txBody>
+          <a:bodyPr/>
+          <a:lstStyle/>
+          <a:p>
+            <a:endParaRPr lang="fr-MA"/>
+          </a:p>
+        </p:txBody>
       </p:sp>
       <p:sp>
         <p:nvSpPr>
@@ -5246,6 +5677,13 @@
           </a:solidFill>
           <a:ln/>
         </p:spPr>
+        <p:txBody>
+          <a:bodyPr/>
+          <a:lstStyle/>
+          <a:p>
+            <a:endParaRPr lang="fr-MA"/>
+          </a:p>
+        </p:txBody>
       </p:sp>
       <p:pic>
         <p:nvPicPr>
@@ -5404,6 +5842,13 @@
             </a:outerShdw>
           </a:effectLst>
         </p:spPr>
+        <p:txBody>
+          <a:bodyPr/>
+          <a:lstStyle/>
+          <a:p>
+            <a:endParaRPr lang="fr-MA"/>
+          </a:p>
+        </p:txBody>
       </p:sp>
       <p:sp>
         <p:nvSpPr>
@@ -5424,6 +5869,13 @@
           </a:solidFill>
           <a:ln/>
         </p:spPr>
+        <p:txBody>
+          <a:bodyPr/>
+          <a:lstStyle/>
+          <a:p>
+            <a:endParaRPr lang="fr-MA"/>
+          </a:p>
+        </p:txBody>
       </p:sp>
       <p:pic>
         <p:nvPicPr>
@@ -5575,6 +6027,13 @@
             <a:prstDash val="solid"/>
           </a:ln>
         </p:spPr>
+        <p:txBody>
+          <a:bodyPr/>
+          <a:lstStyle/>
+          <a:p>
+            <a:endParaRPr lang="fr-MA"/>
+          </a:p>
+        </p:txBody>
       </p:sp>
       <p:pic>
         <p:nvPicPr>
@@ -5700,6 +6159,13 @@
             <a:prstDash val="solid"/>
           </a:ln>
         </p:spPr>
+        <p:txBody>
+          <a:bodyPr/>
+          <a:lstStyle/>
+          <a:p>
+            <a:endParaRPr lang="fr-MA"/>
+          </a:p>
+        </p:txBody>
       </p:sp>
       <p:sp>
         <p:nvSpPr>
@@ -5734,7 +6200,29 @@
                 <a:ea typeface="Calibri" pitchFamily="34" charset="-122"/>
                 <a:cs typeface="Calibri" pitchFamily="34" charset="-120"/>
               </a:rPr>
-              <a:t>Discrete Mathematics  ·  DMath_CC_25  ·  ACSP</a:t>
+              <a:t>Discrete Mathematics  ·  </a:t>
+            </a:r>
+            <a:r>
+              <a:rPr lang="en-US" sz="900" dirty="0" err="1">
+                <a:solidFill>
+                  <a:srgbClr val="64748B"/>
+                </a:solidFill>
+                <a:latin typeface="Calibri" pitchFamily="34" charset="0"/>
+                <a:ea typeface="Calibri" pitchFamily="34" charset="-122"/>
+                <a:cs typeface="Calibri" pitchFamily="34" charset="-120"/>
+              </a:rPr>
+              <a:t>DMath</a:t>
+            </a:r>
+            <a:r>
+              <a:rPr lang="en-US" sz="900" dirty="0">
+                <a:solidFill>
+                  <a:srgbClr val="64748B"/>
+                </a:solidFill>
+                <a:latin typeface="Calibri" pitchFamily="34" charset="0"/>
+                <a:ea typeface="Calibri" pitchFamily="34" charset="-122"/>
+                <a:cs typeface="Calibri" pitchFamily="34" charset="-120"/>
+              </a:rPr>
+              <a:t>  ·  ACSP</a:t>
             </a:r>
             <a:endParaRPr lang="en-US" sz="900" dirty="0"/>
           </a:p>
@@ -5987,6 +6475,13 @@
           </a:solidFill>
           <a:ln/>
         </p:spPr>
+        <p:txBody>
+          <a:bodyPr/>
+          <a:lstStyle/>
+          <a:p>
+            <a:endParaRPr lang="fr-MA"/>
+          </a:p>
+        </p:txBody>
       </p:sp>
       <p:pic>
         <p:nvPicPr>
@@ -6109,6 +6604,13 @@
           </a:solidFill>
           <a:ln/>
         </p:spPr>
+        <p:txBody>
+          <a:bodyPr/>
+          <a:lstStyle/>
+          <a:p>
+            <a:endParaRPr lang="fr-MA"/>
+          </a:p>
+        </p:txBody>
       </p:sp>
       <p:pic>
         <p:nvPicPr>
@@ -6231,6 +6733,13 @@
           </a:solidFill>
           <a:ln/>
         </p:spPr>
+        <p:txBody>
+          <a:bodyPr/>
+          <a:lstStyle/>
+          <a:p>
+            <a:endParaRPr lang="fr-MA"/>
+          </a:p>
+        </p:txBody>
       </p:sp>
       <p:pic>
         <p:nvPicPr>
@@ -6353,6 +6862,13 @@
           </a:solidFill>
           <a:ln/>
         </p:spPr>
+        <p:txBody>
+          <a:bodyPr/>
+          <a:lstStyle/>
+          <a:p>
+            <a:endParaRPr lang="fr-MA"/>
+          </a:p>
+        </p:txBody>
       </p:sp>
       <p:pic>
         <p:nvPicPr>
@@ -6475,6 +6991,13 @@
           </a:solidFill>
           <a:ln/>
         </p:spPr>
+        <p:txBody>
+          <a:bodyPr/>
+          <a:lstStyle/>
+          <a:p>
+            <a:endParaRPr lang="fr-MA"/>
+          </a:p>
+        </p:txBody>
       </p:sp>
       <p:sp>
         <p:nvSpPr>
@@ -6495,6 +7018,13 @@
           </a:solidFill>
           <a:ln/>
         </p:spPr>
+        <p:txBody>
+          <a:bodyPr/>
+          <a:lstStyle/>
+          <a:p>
+            <a:endParaRPr lang="fr-MA"/>
+          </a:p>
+        </p:txBody>
       </p:sp>
       <p:sp>
         <p:nvSpPr>
@@ -6638,17 +7168,19 @@
               <a:buNone/>
             </a:pPr>
             <a:r>
-              <a:rPr lang="en-US" sz="1400" b="1" dirty="0">
+              <a:rPr lang="en-US" sz="1400" b="1">
                 <a:solidFill>
                   <a:srgbClr val="22D3EE"/>
                 </a:solidFill>
-                <a:latin typeface="Georgia" pitchFamily="34" charset="0"/>
+                <a:latin typeface="Georgia"/>
                 <a:ea typeface="Georgia" pitchFamily="34" charset="-122"/>
                 <a:cs typeface="Georgia" pitchFamily="34" charset="-120"/>
               </a:rPr>
-              <a:t>40%</a:t>
-            </a:r>
-            <a:endParaRPr lang="en-US" sz="1400" dirty="0"/>
+              <a:t>20%</a:t>
+            </a:r>
+            <a:endParaRPr lang="en-US" sz="1400">
+              <a:latin typeface="Georgia"/>
+            </a:endParaRPr>
           </a:p>
         </p:txBody>
       </p:sp>
@@ -6674,6 +7206,13 @@
             <a:prstDash val="solid"/>
           </a:ln>
         </p:spPr>
+        <p:txBody>
+          <a:bodyPr/>
+          <a:lstStyle/>
+          <a:p>
+            <a:endParaRPr lang="fr-MA"/>
+          </a:p>
+        </p:txBody>
       </p:sp>
       <p:sp>
         <p:nvSpPr>
@@ -6696,21 +7235,26 @@
           <a:bodyPr wrap="square" lIns="0" tIns="0" rIns="0" bIns="0" rtlCol="0" anchor="ctr"/>
           <a:lstStyle/>
           <a:p>
-            <a:pPr marL="0" indent="0">
-              <a:buNone/>
-            </a:pPr>
+            <a:r>
+              <a:rPr lang="en-US" sz="1300" dirty="0" err="1">
+                <a:solidFill>
+                  <a:srgbClr val="FFFFFF"/>
+                </a:solidFill>
+                <a:ea typeface="Calibri"/>
+                <a:cs typeface="Calibri"/>
+              </a:rPr>
+              <a:t>Miterm</a:t>
+            </a:r>
             <a:r>
               <a:rPr lang="en-US" sz="1300" dirty="0">
                 <a:solidFill>
                   <a:srgbClr val="FFFFFF"/>
                 </a:solidFill>
-                <a:latin typeface="Calibri" pitchFamily="34" charset="0"/>
-                <a:ea typeface="Calibri" pitchFamily="34" charset="-122"/>
-                <a:cs typeface="Calibri" pitchFamily="34" charset="-120"/>
-              </a:rPr>
-              <a:t>Unit quizzes</a:t>
-            </a:r>
-            <a:endParaRPr lang="en-US" sz="1300" dirty="0"/>
+                <a:ea typeface="Calibri"/>
+                <a:cs typeface="Calibri"/>
+              </a:rPr>
+              <a:t> exam</a:t>
+            </a:r>
           </a:p>
         </p:txBody>
       </p:sp>
@@ -6739,17 +7283,19 @@
               <a:buNone/>
             </a:pPr>
             <a:r>
-              <a:rPr lang="en-US" sz="1400" b="1" dirty="0">
+              <a:rPr lang="en-US" sz="1400" b="1">
                 <a:solidFill>
                   <a:srgbClr val="22D3EE"/>
                 </a:solidFill>
-                <a:latin typeface="Georgia" pitchFamily="34" charset="0"/>
+                <a:latin typeface="Georgia"/>
                 <a:ea typeface="Georgia" pitchFamily="34" charset="-122"/>
                 <a:cs typeface="Georgia" pitchFamily="34" charset="-120"/>
               </a:rPr>
-              <a:t>20%</a:t>
-            </a:r>
-            <a:endParaRPr lang="en-US" sz="1400" dirty="0"/>
+              <a:t>30%</a:t>
+            </a:r>
+            <a:endParaRPr lang="en-US" sz="1400">
+              <a:latin typeface="Georgia"/>
+            </a:endParaRPr>
           </a:p>
         </p:txBody>
       </p:sp>
@@ -6775,6 +7321,13 @@
             <a:prstDash val="solid"/>
           </a:ln>
         </p:spPr>
+        <p:txBody>
+          <a:bodyPr/>
+          <a:lstStyle/>
+          <a:p>
+            <a:endParaRPr lang="fr-MA"/>
+          </a:p>
+        </p:txBody>
       </p:sp>
       <p:sp>
         <p:nvSpPr>
@@ -6840,17 +7393,19 @@
               <a:buNone/>
             </a:pPr>
             <a:r>
-              <a:rPr lang="en-US" sz="1400" b="1" dirty="0">
+              <a:rPr lang="en-US" sz="1400" b="1">
                 <a:solidFill>
                   <a:srgbClr val="22D3EE"/>
                 </a:solidFill>
-                <a:latin typeface="Georgia" pitchFamily="34" charset="0"/>
+                <a:latin typeface="Georgia"/>
                 <a:ea typeface="Georgia" pitchFamily="34" charset="-122"/>
                 <a:cs typeface="Georgia" pitchFamily="34" charset="-120"/>
               </a:rPr>
-              <a:t>35%</a:t>
-            </a:r>
-            <a:endParaRPr lang="en-US" sz="1400" dirty="0"/>
+              <a:t>30%</a:t>
+            </a:r>
+            <a:endParaRPr lang="en-US" sz="1400">
+              <a:latin typeface="Georgia"/>
+            </a:endParaRPr>
           </a:p>
         </p:txBody>
       </p:sp>
@@ -6876,6 +7431,13 @@
             <a:prstDash val="solid"/>
           </a:ln>
         </p:spPr>
+        <p:txBody>
+          <a:bodyPr/>
+          <a:lstStyle/>
+          <a:p>
+            <a:endParaRPr lang="fr-MA"/>
+          </a:p>
+        </p:txBody>
       </p:sp>
       <p:sp>
         <p:nvSpPr>
@@ -6902,17 +7464,17 @@
               <a:buNone/>
             </a:pPr>
             <a:r>
-              <a:rPr lang="en-US" sz="1300" dirty="0">
+              <a:rPr lang="en-US" sz="1300" dirty="0" err="1">
                 <a:solidFill>
                   <a:srgbClr val="FFFFFF"/>
                 </a:solidFill>
-                <a:latin typeface="Calibri" pitchFamily="34" charset="0"/>
-                <a:ea typeface="Calibri" pitchFamily="34" charset="-122"/>
-                <a:cs typeface="Calibri" pitchFamily="34" charset="-120"/>
-              </a:rPr>
-              <a:t>Participation</a:t>
-            </a:r>
-            <a:endParaRPr lang="en-US" sz="1300" dirty="0"/>
+                <a:latin typeface="Calibri"/>
+                <a:ea typeface="Calibri"/>
+                <a:cs typeface="Calibri"/>
+              </a:rPr>
+              <a:t>Paresentation</a:t>
+            </a:r>
+            <a:endParaRPr lang="en-US" sz="1300" dirty="0" err="1"/>
           </a:p>
         </p:txBody>
       </p:sp>
@@ -6941,17 +7503,19 @@
               <a:buNone/>
             </a:pPr>
             <a:r>
-              <a:rPr lang="en-US" sz="1400" b="1" dirty="0">
+              <a:rPr lang="en-US" sz="1400" b="1">
                 <a:solidFill>
                   <a:srgbClr val="22D3EE"/>
                 </a:solidFill>
-                <a:latin typeface="Georgia" pitchFamily="34" charset="0"/>
+                <a:latin typeface="Georgia"/>
                 <a:ea typeface="Georgia" pitchFamily="34" charset="-122"/>
                 <a:cs typeface="Georgia" pitchFamily="34" charset="-120"/>
               </a:rPr>
-              <a:t>5%</a:t>
-            </a:r>
-            <a:endParaRPr lang="en-US" sz="1400" dirty="0"/>
+              <a:t>20%</a:t>
+            </a:r>
+            <a:endParaRPr lang="en-US" sz="1400">
+              <a:latin typeface="Georgia"/>
+            </a:endParaRPr>
           </a:p>
         </p:txBody>
       </p:sp>
@@ -6977,43 +7541,11 @@
             <a:prstDash val="solid"/>
           </a:ln>
         </p:spPr>
-      </p:sp>
-      <p:sp>
-        <p:nvSpPr>
-          <p:cNvPr id="38" name="Text 32"/>
-          <p:cNvSpPr/>
-          <p:nvPr/>
-        </p:nvSpPr>
-        <p:spPr>
-          <a:xfrm>
-            <a:off x="7132320" y="5257800"/>
-            <a:ext cx="4114800" cy="502920"/>
-          </a:xfrm>
-          <a:prstGeom prst="rect">
-            <a:avLst/>
-          </a:prstGeom>
-          <a:noFill/>
-          <a:ln/>
-        </p:spPr>
-        <p:txBody>
-          <a:bodyPr wrap="square" lIns="0" tIns="0" rIns="0" bIns="0" rtlCol="0" anchor="ctr"/>
-          <a:lstStyle/>
-          <a:p>
-            <a:pPr marL="0" indent="0">
-              <a:buNone/>
-            </a:pPr>
-            <a:r>
-              <a:rPr lang="en-US" sz="1050" i="1" dirty="0">
-                <a:solidFill>
-                  <a:srgbClr val="CBD5E1"/>
-                </a:solidFill>
-                <a:latin typeface="Calibri" pitchFamily="34" charset="0"/>
-                <a:ea typeface="Calibri" pitchFamily="34" charset="-122"/>
-                <a:cs typeface="Calibri" pitchFamily="34" charset="-120"/>
-              </a:rPr>
-              <a:t>After Sequence 7 you choose your specialisation: Data or Cyber pathway.</a:t>
-            </a:r>
-            <a:endParaRPr lang="en-US" sz="1050" dirty="0"/>
+        <p:txBody>
+          <a:bodyPr/>
+          <a:lstStyle/>
+          <a:p>
+            <a:endParaRPr lang="fr-MA"/>
           </a:p>
         </p:txBody>
       </p:sp>
@@ -7039,6 +7571,13 @@
             <a:prstDash val="solid"/>
           </a:ln>
         </p:spPr>
+        <p:txBody>
+          <a:bodyPr/>
+          <a:lstStyle/>
+          <a:p>
+            <a:endParaRPr lang="fr-MA"/>
+          </a:p>
+        </p:txBody>
       </p:sp>
       <p:sp>
         <p:nvSpPr>
@@ -7073,7 +7612,29 @@
                 <a:ea typeface="Calibri" pitchFamily="34" charset="-122"/>
                 <a:cs typeface="Calibri" pitchFamily="34" charset="-120"/>
               </a:rPr>
-              <a:t>Discrete Mathematics  ·  DMath_CC_25  ·  ACSP</a:t>
+              <a:t>Discrete Mathematics  ·  </a:t>
+            </a:r>
+            <a:r>
+              <a:rPr lang="en-US" sz="900" dirty="0" err="1">
+                <a:solidFill>
+                  <a:srgbClr val="64748B"/>
+                </a:solidFill>
+                <a:latin typeface="Calibri" pitchFamily="34" charset="0"/>
+                <a:ea typeface="Calibri" pitchFamily="34" charset="-122"/>
+                <a:cs typeface="Calibri" pitchFamily="34" charset="-120"/>
+              </a:rPr>
+              <a:t>DMath</a:t>
+            </a:r>
+            <a:r>
+              <a:rPr lang="en-US" sz="900" dirty="0">
+                <a:solidFill>
+                  <a:srgbClr val="64748B"/>
+                </a:solidFill>
+                <a:latin typeface="Calibri" pitchFamily="34" charset="0"/>
+                <a:ea typeface="Calibri" pitchFamily="34" charset="-122"/>
+                <a:cs typeface="Calibri" pitchFamily="34" charset="-120"/>
+              </a:rPr>
+              <a:t>  ·  ACSP</a:t>
             </a:r>
             <a:endParaRPr lang="en-US" sz="900" dirty="0"/>
           </a:p>
@@ -7272,6 +7833,13 @@
           </a:solidFill>
           <a:ln/>
         </p:spPr>
+        <p:txBody>
+          <a:bodyPr/>
+          <a:lstStyle/>
+          <a:p>
+            <a:endParaRPr lang="fr-MA"/>
+          </a:p>
+        </p:txBody>
       </p:sp>
       <p:sp>
         <p:nvSpPr>
@@ -7292,6 +7860,13 @@
           </a:solidFill>
           <a:ln/>
         </p:spPr>
+        <p:txBody>
+          <a:bodyPr/>
+          <a:lstStyle/>
+          <a:p>
+            <a:endParaRPr lang="fr-MA"/>
+          </a:p>
+        </p:txBody>
       </p:sp>
       <p:pic>
         <p:nvPicPr>
@@ -7375,6 +7950,13 @@
           </a:solidFill>
           <a:ln/>
         </p:spPr>
+        <p:txBody>
+          <a:bodyPr/>
+          <a:lstStyle/>
+          <a:p>
+            <a:endParaRPr lang="fr-MA"/>
+          </a:p>
+        </p:txBody>
       </p:sp>
       <p:pic>
         <p:nvPicPr>
@@ -7458,6 +8040,13 @@
           </a:solidFill>
           <a:ln/>
         </p:spPr>
+        <p:txBody>
+          <a:bodyPr/>
+          <a:lstStyle/>
+          <a:p>
+            <a:endParaRPr lang="fr-MA"/>
+          </a:p>
+        </p:txBody>
       </p:sp>
       <p:pic>
         <p:nvPicPr>
@@ -7547,7 +8136,7 @@
               <a:buNone/>
             </a:pPr>
             <a:r>
-              <a:rPr lang="en-US" sz="1200">
+              <a:rPr lang="en-US" sz="1200" dirty="0">
                 <a:solidFill>
                   <a:srgbClr val="94A3B8"/>
                 </a:solidFill>
@@ -7555,49 +8144,49 @@
                 <a:ea typeface="Calibri" pitchFamily="34" charset="-122"/>
                 <a:cs typeface="Calibri" pitchFamily="34" charset="-120"/>
               </a:rPr>
-              <a:t>Zouhair El Hadiq·   </a:t>
-            </a:r>
-            <a:r>
-              <a:rPr lang="en-US" sz="1200" dirty="0">
-                <a:solidFill>
-                  <a:srgbClr val="94A3B8"/>
+              <a:t>Zouhair El Hadiq·   Ismail Bouishakk</a:t>
+            </a:r>
+            <a:endParaRPr lang="en-US" sz="1200" dirty="0"/>
+          </a:p>
+        </p:txBody>
+      </p:sp>
+      <p:sp>
+        <p:nvSpPr>
+          <p:cNvPr id="16" name="Text 10"/>
+          <p:cNvSpPr/>
+          <p:nvPr/>
+        </p:nvSpPr>
+        <p:spPr>
+          <a:xfrm>
+            <a:off x="548640" y="6355080"/>
+            <a:ext cx="11064240" cy="274320"/>
+          </a:xfrm>
+          <a:prstGeom prst="rect">
+            <a:avLst/>
+          </a:prstGeom>
+          <a:noFill/>
+          <a:ln/>
+        </p:spPr>
+        <p:txBody>
+          <a:bodyPr wrap="square" lIns="0" tIns="0" rIns="0" bIns="0" rtlCol="0" anchor="ctr"/>
+          <a:lstStyle/>
+          <a:p>
+            <a:pPr marL="0" indent="0" algn="ctr">
+              <a:buNone/>
+            </a:pPr>
+            <a:r>
+              <a:rPr lang="en-US" sz="1000" kern="0" spc="200" dirty="0">
+                <a:solidFill>
+                  <a:srgbClr val="64748B"/>
                 </a:solidFill>
                 <a:latin typeface="Calibri" pitchFamily="34" charset="0"/>
                 <a:ea typeface="Calibri" pitchFamily="34" charset="-122"/>
                 <a:cs typeface="Calibri" pitchFamily="34" charset="-120"/>
               </a:rPr>
-              <a:t>Ismail Bouisha</a:t>
-            </a:r>
-            <a:endParaRPr lang="en-US" sz="1200" dirty="0"/>
-          </a:p>
-        </p:txBody>
-      </p:sp>
-      <p:sp>
-        <p:nvSpPr>
-          <p:cNvPr id="16" name="Text 10"/>
-          <p:cNvSpPr/>
-          <p:nvPr/>
-        </p:nvSpPr>
-        <p:spPr>
-          <a:xfrm>
-            <a:off x="548640" y="6355080"/>
-            <a:ext cx="11064240" cy="274320"/>
-          </a:xfrm>
-          <a:prstGeom prst="rect">
-            <a:avLst/>
-          </a:prstGeom>
-          <a:noFill/>
-          <a:ln/>
-        </p:spPr>
-        <p:txBody>
-          <a:bodyPr wrap="square" lIns="0" tIns="0" rIns="0" bIns="0" rtlCol="0" anchor="ctr"/>
-          <a:lstStyle/>
-          <a:p>
-            <a:pPr marL="0" indent="0" algn="ctr">
-              <a:buNone/>
-            </a:pPr>
-            <a:r>
-              <a:rPr lang="en-US" sz="1000" kern="0" spc="200" dirty="0">
+              <a:t>Discrete Mathematics  ·  </a:t>
+            </a:r>
+            <a:r>
+              <a:rPr lang="en-US" sz="1000" kern="0" spc="200" dirty="0" err="1">
                 <a:solidFill>
                   <a:srgbClr val="64748B"/>
                 </a:solidFill>
@@ -7605,7 +8194,18 @@
                 <a:ea typeface="Calibri" pitchFamily="34" charset="-122"/>
                 <a:cs typeface="Calibri" pitchFamily="34" charset="-120"/>
               </a:rPr>
-              <a:t>Discrete Mathematics  ·  DMath_CC_25  ·  ACSP</a:t>
+              <a:t>DMath</a:t>
+            </a:r>
+            <a:r>
+              <a:rPr lang="en-US" sz="1000" kern="0" spc="200" dirty="0">
+                <a:solidFill>
+                  <a:srgbClr val="64748B"/>
+                </a:solidFill>
+                <a:latin typeface="Calibri" pitchFamily="34" charset="0"/>
+                <a:ea typeface="Calibri" pitchFamily="34" charset="-122"/>
+                <a:cs typeface="Calibri" pitchFamily="34" charset="-120"/>
+              </a:rPr>
+              <a:t>  ·  ACSP</a:t>
             </a:r>
             <a:endParaRPr lang="en-US" sz="1000" dirty="0"/>
           </a:p>

</xml_diff>